<commit_message>
Add Matthew 12:14-21 to the Lord's Supper reading index
New index 105, NASB95 English / RVR1960 Spanish, matching the pattern
used for indexes 103-104.

🤖 Generated with Claude Code at The Home Depot

Co-Authored-By: Claude <noreply@anthropic.com>
</commit_message>
<xml_diff>
--- a/assets/readings-supper.pptx
+++ b/assets/readings-supper.pptx
@@ -110,6 +110,7 @@
     <p:sldId id="360" r:id="rId104"/>
     <p:sldId id="361" r:id="rId109"/>
     <p:sldId id="362" r:id="rId110"/>
+    <p:sldId id="363" r:id="rId111"/>
   </p:sldIdLst>
   <p:sldSz cx="12192000" cy="6858000"/>
   <p:notesSz cx="6858000" cy="9144000"/>
@@ -2288,6 +2289,132 @@
 </p:sld>
 </file>
 
+<file path=ppt/slides/slide106.xml><?xml version="1.0" encoding="utf-8"?>
+<p:sld xmlns:a="http://schemas.openxmlformats.org/drawingml/2006/main" xmlns:p="http://schemas.openxmlformats.org/presentationml/2006/main" xmlns:r="http://schemas.openxmlformats.org/officeDocument/2006/relationships">
+  <p:cSld>
+    <p:spTree>
+      <p:nvGrpSpPr>
+        <p:cNvPr id="1" name=""/>
+        <p:cNvGrpSpPr/>
+        <p:nvPr/>
+      </p:nvGrpSpPr>
+      <p:grpSpPr/>
+      <p:sp>
+        <p:nvSpPr>
+          <p:cNvPr id="4" name="Text Placeholder 3">
+            <a:extLst>
+              <a:ext uri="{FF2B5EF4-FFF2-40B4-BE49-F238E27FC236}">
+                <a16:creationId xmlns:a16="http://schemas.microsoft.com/office/drawing/2014/main" id="{DFD9D55F-EF00-CB99-E3DF-A541273F03E7}"/>
+              </a:ext>
+            </a:extLst>
+          </p:cNvPr>
+          <p:cNvSpPr>
+            <a:spLocks noGrp="1"/>
+          </p:cNvSpPr>
+          <p:nvPr>
+            <p:ph type="body" sz="quarter" idx="10"/>
+          </p:nvPr>
+        </p:nvSpPr>
+        <p:spPr/>
+        <p:txBody>
+          <a:bodyPr/>
+          <a:lstStyle/>
+          <a:p>
+            <a:r>
+              <a:t>Matthew 12:14-21</a:t>
+            </a:r>
+          </a:p>
+        </p:txBody>
+      </p:sp>
+      <p:sp>
+        <p:nvSpPr>
+          <p:cNvPr id="5" name="Text Placeholder 4">
+            <a:extLst>
+              <a:ext uri="{FF2B5EF4-FFF2-40B4-BE49-F238E27FC236}">
+                <a16:creationId xmlns:a16="http://schemas.microsoft.com/office/drawing/2014/main" id="{183C6CE0-2BF5-9A80-AAF9-98602288B00B}"/>
+              </a:ext>
+            </a:extLst>
+          </p:cNvPr>
+          <p:cNvSpPr>
+            <a:spLocks noGrp="1"/>
+          </p:cNvSpPr>
+          <p:nvPr>
+            <p:ph type="body" sz="quarter" idx="11"/>
+          </p:nvPr>
+        </p:nvSpPr>
+        <p:spPr/>
+        <p:txBody>
+          <a:bodyPr/>
+          <a:lstStyle/>
+          <a:p>
+            <a:r>
+              <a:t>Mateo 12:14-21</a:t>
+            </a:r>
+          </a:p>
+        </p:txBody>
+      </p:sp>
+      <p:sp>
+        <p:nvSpPr>
+          <p:cNvPr id="6" name="Text Placeholder 5">
+            <a:extLst>
+              <a:ext uri="{FF2B5EF4-FFF2-40B4-BE49-F238E27FC236}">
+                <a16:creationId xmlns:a16="http://schemas.microsoft.com/office/drawing/2014/main" id="{E3687956-5B1E-E87A-C63F-2CF83852F74A}"/>
+              </a:ext>
+            </a:extLst>
+          </p:cNvPr>
+          <p:cNvSpPr>
+            <a:spLocks noGrp="1"/>
+          </p:cNvSpPr>
+          <p:nvPr>
+            <p:ph type="body" sz="quarter" idx="12"/>
+          </p:nvPr>
+        </p:nvSpPr>
+        <p:spPr/>
+        <p:txBody>
+          <a:bodyPr/>
+          <a:lstStyle/>
+          <a:p>
+            <a:r>
+              <a:t>But the Pharisees went out and conspired against Him, as to how they might destroy Him. But Jesus, aware of this, withdrew from there. Many followed Him, and He healed them all, and warned them not to tell who He was. This was to fulfill what was spoken through Isaiah the prophet: “Behold, My Servant whom I have chosen; My Beloved in whom My soul is well-pleased; I will put My Spirit upon Him, And He shall proclaim justice to the Gentiles. He will not quarrel, nor cry out; Nor will anyone hear His voice in the streets. A battered reed He will not break off, And a smoldering wick He will not put out, Until He leads justice to victory. And in His name the Gentiles will hope.”</a:t>
+            </a:r>
+          </a:p>
+        </p:txBody>
+      </p:sp>
+      <p:sp>
+        <p:nvSpPr>
+          <p:cNvPr id="7" name="Text Placeholder 6">
+            <a:extLst>
+              <a:ext uri="{FF2B5EF4-FFF2-40B4-BE49-F238E27FC236}">
+                <a16:creationId xmlns:a16="http://schemas.microsoft.com/office/drawing/2014/main" id="{939E2508-EFDC-0849-203A-1E6D24D54960}"/>
+              </a:ext>
+            </a:extLst>
+          </p:cNvPr>
+          <p:cNvSpPr>
+            <a:spLocks noGrp="1"/>
+          </p:cNvSpPr>
+          <p:nvPr>
+            <p:ph type="body" sz="quarter" idx="13"/>
+          </p:nvPr>
+        </p:nvSpPr>
+        <p:spPr/>
+        <p:txBody>
+          <a:bodyPr/>
+          <a:lstStyle/>
+          <a:p>
+            <a:r>
+              <a:t>Y salieron los fariseos, y tuvieron consejo contra él para destruirle. Sabiendo esto Jesús, se apartó de allí; y le siguió mucha gente, y sanaba a todos, y les encargaba rigurosamente que no le descubriesen; para que se cumpliese lo dicho por el profeta Isaías, cuando dijo: He aquí mi siervo, a quien he escogido; Mi Amado, en quien se agrada mi alma; Pondré mi Espíritu sobre él, Y a los gentiles anunciará juicio. No contenderá, ni voceará, Ni nadie oirá en las calles su voz. La caña cascada no quebrará, Y el pábilo que humea no apagará, Hasta que saque a victoria el juicio. Y en su nombre esperarán los gentiles.</a:t>
+            </a:r>
+          </a:p>
+        </p:txBody>
+      </p:sp>
+    </p:spTree>
+  </p:cSld>
+  <p:clrMapOvr>
+    <a:masterClrMapping/>
+  </p:clrMapOvr>
+</p:sld>
+</file>
+
 <file path=ppt/slides/slide11.xml><?xml version="1.0" encoding="utf-8"?>
 <p:sld xmlns:a="http://schemas.openxmlformats.org/drawingml/2006/main" xmlns:r="http://schemas.openxmlformats.org/officeDocument/2006/relationships" xmlns:p="http://schemas.openxmlformats.org/presentationml/2006/main">
   <p:cSld>

</xml_diff>